<commit_message>
update type along exercise using ubuntu image and installation of cowsay
</commit_message>
<xml_diff>
--- a/docker/02_Container_Lifecycle.pptx
+++ b/docker/02_Container_Lifecycle.pptx
@@ -15,11 +15,11 @@
     <p:sldId id="515" r:id="rId6"/>
     <p:sldId id="516" r:id="rId7"/>
     <p:sldId id="458" r:id="rId8"/>
-    <p:sldId id="519" r:id="rId9"/>
+    <p:sldId id="525" r:id="rId9"/>
     <p:sldId id="521" r:id="rId10"/>
     <p:sldId id="520" r:id="rId11"/>
     <p:sldId id="518" r:id="rId12"/>
-    <p:sldId id="522" r:id="rId13"/>
+    <p:sldId id="526" r:id="rId13"/>
     <p:sldId id="453" r:id="rId14"/>
     <p:sldId id="524" r:id="rId15"/>
     <p:sldId id="382" r:id="rId16"/>
@@ -213,6 +213,77 @@
 </p:cmAuthorLst>
 </file>
 
+<file path=ppt/revisionInfo.xml><?xml version="1.0" encoding="utf-8"?>
+<p1510:revInfo xmlns:a="http://schemas.openxmlformats.org/drawingml/2006/main" xmlns:r="http://schemas.openxmlformats.org/officeDocument/2006/relationships" xmlns:p1510="http://schemas.microsoft.com/office/powerpoint/2015/10/main">
+  <p1510:revLst>
+    <p1510:client id="{699189EE-032E-0444-8C4A-50446509CBC5}" v="5" dt="2023-07-07T12:55:29.475"/>
+  </p1510:revLst>
+</p1510:revInfo>
+</file>
+
+<file path=ppt/changesInfos/changesInfo1.xml><?xml version="1.0" encoding="utf-8"?>
+<pc:chgInfo xmlns:a="http://schemas.openxmlformats.org/drawingml/2006/main" xmlns:r="http://schemas.openxmlformats.org/officeDocument/2006/relationships" xmlns:ac="http://schemas.microsoft.com/office/drawing/2013/main/command" xmlns:pc="http://schemas.microsoft.com/office/powerpoint/2013/main/command">
+  <pc:docChgLst>
+    <pc:chgData name="Duong, Lena Thanh-Van" userId="974e8cb6-c096-41f9-96cc-0ba26e22fdad" providerId="ADAL" clId="{699189EE-032E-0444-8C4A-50446509CBC5}"/>
+    <pc:docChg chg="addSld delSld modSld">
+      <pc:chgData name="Duong, Lena Thanh-Van" userId="974e8cb6-c096-41f9-96cc-0ba26e22fdad" providerId="ADAL" clId="{699189EE-032E-0444-8C4A-50446509CBC5}" dt="2023-07-07T12:55:31.291" v="9" actId="2696"/>
+      <pc:docMkLst>
+        <pc:docMk/>
+      </pc:docMkLst>
+      <pc:sldChg chg="add del">
+        <pc:chgData name="Duong, Lena Thanh-Van" userId="974e8cb6-c096-41f9-96cc-0ba26e22fdad" providerId="ADAL" clId="{699189EE-032E-0444-8C4A-50446509CBC5}" dt="2023-07-07T12:55:11.517" v="7"/>
+        <pc:sldMkLst>
+          <pc:docMk/>
+          <pc:sldMk cId="2875838750" sldId="516"/>
+        </pc:sldMkLst>
+      </pc:sldChg>
+      <pc:sldChg chg="del">
+        <pc:chgData name="Duong, Lena Thanh-Van" userId="974e8cb6-c096-41f9-96cc-0ba26e22fdad" providerId="ADAL" clId="{699189EE-032E-0444-8C4A-50446509CBC5}" dt="2023-07-07T12:54:43.940" v="1" actId="2696"/>
+        <pc:sldMkLst>
+          <pc:docMk/>
+          <pc:sldMk cId="1257255272" sldId="519"/>
+        </pc:sldMkLst>
+      </pc:sldChg>
+      <pc:sldChg chg="add del">
+        <pc:chgData name="Duong, Lena Thanh-Van" userId="974e8cb6-c096-41f9-96cc-0ba26e22fdad" providerId="ADAL" clId="{699189EE-032E-0444-8C4A-50446509CBC5}" dt="2023-07-07T12:54:57.506" v="5"/>
+        <pc:sldMkLst>
+          <pc:docMk/>
+          <pc:sldMk cId="2683662626" sldId="520"/>
+        </pc:sldMkLst>
+      </pc:sldChg>
+      <pc:sldChg chg="add del">
+        <pc:chgData name="Duong, Lena Thanh-Van" userId="974e8cb6-c096-41f9-96cc-0ba26e22fdad" providerId="ADAL" clId="{699189EE-032E-0444-8C4A-50446509CBC5}" dt="2023-07-07T12:54:53.488" v="4"/>
+        <pc:sldMkLst>
+          <pc:docMk/>
+          <pc:sldMk cId="3235407943" sldId="521"/>
+        </pc:sldMkLst>
+      </pc:sldChg>
+      <pc:sldChg chg="del">
+        <pc:chgData name="Duong, Lena Thanh-Van" userId="974e8cb6-c096-41f9-96cc-0ba26e22fdad" providerId="ADAL" clId="{699189EE-032E-0444-8C4A-50446509CBC5}" dt="2023-07-07T12:55:31.291" v="9" actId="2696"/>
+        <pc:sldMkLst>
+          <pc:docMk/>
+          <pc:sldMk cId="798876502" sldId="522"/>
+        </pc:sldMkLst>
+      </pc:sldChg>
+      <pc:sldChg chg="add">
+        <pc:chgData name="Duong, Lena Thanh-Van" userId="974e8cb6-c096-41f9-96cc-0ba26e22fdad" providerId="ADAL" clId="{699189EE-032E-0444-8C4A-50446509CBC5}" dt="2023-07-07T12:54:41.560" v="0"/>
+        <pc:sldMkLst>
+          <pc:docMk/>
+          <pc:sldMk cId="4006759392" sldId="525"/>
+        </pc:sldMkLst>
+      </pc:sldChg>
+      <pc:sldChg chg="add">
+        <pc:chgData name="Duong, Lena Thanh-Van" userId="974e8cb6-c096-41f9-96cc-0ba26e22fdad" providerId="ADAL" clId="{699189EE-032E-0444-8C4A-50446509CBC5}" dt="2023-07-07T12:55:29.469" v="8"/>
+        <pc:sldMkLst>
+          <pc:docMk/>
+          <pc:sldMk cId="3895770100" sldId="526"/>
+        </pc:sldMkLst>
+      </pc:sldChg>
+    </pc:docChg>
+  </pc:docChgLst>
+</pc:chgInfo>
+</file>
+
 <file path=ppt/handoutMasters/handoutMaster1.xml><?xml version="1.0" encoding="utf-8"?>
 <p:handoutMaster xmlns:a="http://schemas.openxmlformats.org/drawingml/2006/main" xmlns:r="http://schemas.openxmlformats.org/officeDocument/2006/relationships" xmlns:p="http://schemas.openxmlformats.org/presentationml/2006/main">
   <p:cSld>
@@ -266,7 +337,7 @@
             <a:fld id="{47855BD9-AF71-426C-9B9B-B0E52B88852E}" type="slidenum">
               <a:rPr lang="de-DE" sz="1000" smtClean="0"/>
               <a:pPr algn="ctr"/>
-              <a:t>‹Nr.›</a:t>
+              <a:t>‹#›</a:t>
             </a:fld>
             <a:endParaRPr lang="de-DE" sz="1000" dirty="0"/>
           </a:p>
@@ -415,7 +486,7 @@
             <a:fld id="{7D8C2C35-2B8A-446E-BEC0-FD36716C29AC}" type="slidenum">
               <a:rPr lang="de-DE" smtClean="0"/>
               <a:pPr/>
-              <a:t>‹Nr.›</a:t>
+              <a:t>‹#›</a:t>
             </a:fld>
             <a:endParaRPr lang="de-DE" dirty="0"/>
           </a:p>
@@ -14462,7 +14533,7 @@
               <a:pPr marL="0" lvl="0" indent="0" algn="r">
                 <a:buNone/>
               </a:pPr>
-              <a:t>‹Nr.›</a:t>
+              <a:t>‹#›</a:t>
             </a:fld>
             <a:endParaRPr lang="en-US" sz="900" noProof="0" dirty="0"/>
           </a:p>
@@ -20646,32 +20717,13 @@
                 <a:ea typeface="Arial Unicode MS" pitchFamily="34" charset="-128"/>
                 <a:cs typeface="Courier New" panose="02070309020205020404" pitchFamily="49" charset="0"/>
               </a:rPr>
-              <a:t>docker</a:t>
-            </a:r>
-            <a:r>
-              <a:rPr lang="de-DE" sz="1800" kern="0" dirty="0">
-                <a:latin typeface="Courier New" panose="02070309020205020404" pitchFamily="49" charset="0"/>
-                <a:ea typeface="Arial Unicode MS" pitchFamily="34" charset="-128"/>
-                <a:cs typeface="Courier New" panose="02070309020205020404" pitchFamily="49" charset="0"/>
-              </a:rPr>
-              <a:t>/</a:t>
-            </a:r>
-            <a:r>
-              <a:rPr lang="de-DE" sz="1800" kern="0" dirty="0" err="1">
-                <a:latin typeface="Courier New" panose="02070309020205020404" pitchFamily="49" charset="0"/>
-                <a:ea typeface="Arial Unicode MS" pitchFamily="34" charset="-128"/>
-                <a:cs typeface="Courier New" panose="02070309020205020404" pitchFamily="49" charset="0"/>
-              </a:rPr>
-              <a:t>whalesay</a:t>
-            </a:r>
-            <a:r>
-              <a:rPr lang="de-DE" sz="1800" kern="0" dirty="0">
-                <a:latin typeface="Courier New" panose="02070309020205020404" pitchFamily="49" charset="0"/>
-                <a:ea typeface="Arial Unicode MS" pitchFamily="34" charset="-128"/>
-                <a:cs typeface="Courier New" panose="02070309020205020404" pitchFamily="49" charset="0"/>
-              </a:rPr>
-              <a:t> </a:t>
-            </a:r>
+              <a:t>ubuntu:latest</a:t>
+            </a:r>
+            <a:endParaRPr lang="de-DE" sz="1800" kern="0" dirty="0">
+              <a:latin typeface="Courier New" panose="02070309020205020404" pitchFamily="49" charset="0"/>
+              <a:ea typeface="Arial Unicode MS" pitchFamily="34" charset="-128"/>
+              <a:cs typeface="Courier New" panose="02070309020205020404" pitchFamily="49" charset="0"/>
+            </a:endParaRPr>
           </a:p>
         </p:txBody>
       </p:sp>
@@ -22732,10 +22784,10 @@
       </p:sp>
       <p:sp>
         <p:nvSpPr>
-          <p:cNvPr id="3" name="Textfeld 2">
+          <p:cNvPr id="4" name="Textfeld 2">
             <a:extLst>
               <a:ext uri="{FF2B5EF4-FFF2-40B4-BE49-F238E27FC236}">
-                <a16:creationId xmlns:a16="http://schemas.microsoft.com/office/drawing/2014/main" id="{3796437A-8539-847E-5ABD-D965AB464BBD}"/>
+                <a16:creationId xmlns:a16="http://schemas.microsoft.com/office/drawing/2014/main" id="{8921AD4C-1D7C-6C17-51E4-38B23E96A847}"/>
               </a:ext>
             </a:extLst>
           </p:cNvPr>
@@ -22744,8 +22796,8 @@
         </p:nvSpPr>
         <p:spPr>
           <a:xfrm>
-            <a:off x="504001" y="1576570"/>
-            <a:ext cx="8667708" cy="3704860"/>
+            <a:off x="504001" y="1299572"/>
+            <a:ext cx="8667708" cy="4258858"/>
           </a:xfrm>
           <a:prstGeom prst="rect">
             <a:avLst/>
@@ -22835,7 +22887,23 @@
                 <a:ea typeface="Arial Unicode MS" pitchFamily="34" charset="-128"/>
                 <a:cs typeface="Courier New" panose="02070309020205020404" pitchFamily="49" charset="0"/>
               </a:rPr>
-              <a:t>help</a:t>
+              <a:t>it</a:t>
+            </a:r>
+            <a:r>
+              <a:rPr lang="de-DE" sz="1800" kern="0" dirty="0">
+                <a:latin typeface="Courier New" panose="02070309020205020404" pitchFamily="49" charset="0"/>
+                <a:ea typeface="Arial Unicode MS" pitchFamily="34" charset="-128"/>
+                <a:cs typeface="Courier New" panose="02070309020205020404" pitchFamily="49" charset="0"/>
+              </a:rPr>
+              <a:t> </a:t>
+            </a:r>
+            <a:r>
+              <a:rPr lang="de-DE" sz="1800" kern="0" dirty="0" err="1">
+                <a:latin typeface="Courier New" panose="02070309020205020404" pitchFamily="49" charset="0"/>
+                <a:ea typeface="Arial Unicode MS" pitchFamily="34" charset="-128"/>
+                <a:cs typeface="Courier New" panose="02070309020205020404" pitchFamily="49" charset="0"/>
+              </a:rPr>
+              <a:t>ubuntu:latest</a:t>
             </a:r>
             <a:endParaRPr lang="de-DE" sz="1800" kern="0" dirty="0">
               <a:latin typeface="Courier New" panose="02070309020205020404" pitchFamily="49" charset="0"/>
@@ -22905,7 +22973,7 @@
                 <a:ea typeface="Arial Unicode MS" pitchFamily="34" charset="-128"/>
                 <a:cs typeface="Courier New" panose="02070309020205020404" pitchFamily="49" charset="0"/>
               </a:rPr>
-              <a:t>create</a:t>
+              <a:t>list</a:t>
             </a:r>
             <a:r>
               <a:rPr lang="de-DE" sz="1800" kern="0" dirty="0">
@@ -22913,7 +22981,32 @@
                 <a:ea typeface="Arial Unicode MS" pitchFamily="34" charset="-128"/>
                 <a:cs typeface="Courier New" panose="02070309020205020404" pitchFamily="49" charset="0"/>
               </a:rPr>
-              <a:t> –</a:t>
+              <a:t> –a</a:t>
+            </a:r>
+          </a:p>
+          <a:p>
+            <a:pPr fontAlgn="base">
+              <a:lnSpc>
+                <a:spcPct val="150000"/>
+              </a:lnSpc>
+              <a:spcBef>
+                <a:spcPct val="50000"/>
+              </a:spcBef>
+              <a:spcAft>
+                <a:spcPct val="0"/>
+              </a:spcAft>
+              <a:buClr>
+                <a:srgbClr val="F0AB00"/>
+              </a:buClr>
+              <a:buSzPct val="80000"/>
+            </a:pPr>
+            <a:r>
+              <a:rPr lang="de-DE" sz="1800" kern="0" dirty="0">
+                <a:latin typeface="Courier New" panose="02070309020205020404" pitchFamily="49" charset="0"/>
+                <a:ea typeface="Arial Unicode MS" pitchFamily="34" charset="-128"/>
+                <a:cs typeface="Courier New" panose="02070309020205020404" pitchFamily="49" charset="0"/>
+              </a:rPr>
+              <a:t>$: </a:t>
             </a:r>
             <a:r>
               <a:rPr lang="de-DE" sz="1800" kern="0" dirty="0" err="1">
@@ -22921,7 +23014,7 @@
                 <a:ea typeface="Arial Unicode MS" pitchFamily="34" charset="-128"/>
                 <a:cs typeface="Courier New" panose="02070309020205020404" pitchFamily="49" charset="0"/>
               </a:rPr>
-              <a:t>it</a:t>
+              <a:t>docker</a:t>
             </a:r>
             <a:r>
               <a:rPr lang="de-DE" sz="1800" kern="0" dirty="0">
@@ -22937,7 +23030,7 @@
                 <a:ea typeface="Arial Unicode MS" pitchFamily="34" charset="-128"/>
                 <a:cs typeface="Courier New" panose="02070309020205020404" pitchFamily="49" charset="0"/>
               </a:rPr>
-              <a:t>docker</a:t>
+              <a:t>container</a:t>
             </a:r>
             <a:r>
               <a:rPr lang="de-DE" sz="1800" kern="0" dirty="0">
@@ -22945,7 +23038,7 @@
                 <a:ea typeface="Arial Unicode MS" pitchFamily="34" charset="-128"/>
                 <a:cs typeface="Courier New" panose="02070309020205020404" pitchFamily="49" charset="0"/>
               </a:rPr>
-              <a:t>/</a:t>
+              <a:t> </a:t>
             </a:r>
             <a:r>
               <a:rPr lang="de-DE" sz="1800" kern="0" dirty="0" err="1">
@@ -22953,7 +23046,185 @@
                 <a:ea typeface="Arial Unicode MS" pitchFamily="34" charset="-128"/>
                 <a:cs typeface="Courier New" panose="02070309020205020404" pitchFamily="49" charset="0"/>
               </a:rPr>
-              <a:t>whalesay</a:t>
+              <a:t>start</a:t>
+            </a:r>
+            <a:r>
+              <a:rPr lang="de-DE" sz="1800" kern="0" dirty="0">
+                <a:latin typeface="Courier New" panose="02070309020205020404" pitchFamily="49" charset="0"/>
+                <a:ea typeface="Arial Unicode MS" pitchFamily="34" charset="-128"/>
+                <a:cs typeface="Courier New" panose="02070309020205020404" pitchFamily="49" charset="0"/>
+              </a:rPr>
+              <a:t> –i &lt;</a:t>
+            </a:r>
+            <a:r>
+              <a:rPr lang="de-DE" sz="1800" kern="0" dirty="0" err="1">
+                <a:latin typeface="Courier New" panose="02070309020205020404" pitchFamily="49" charset="0"/>
+                <a:ea typeface="Arial Unicode MS" pitchFamily="34" charset="-128"/>
+                <a:cs typeface="Courier New" panose="02070309020205020404" pitchFamily="49" charset="0"/>
+              </a:rPr>
+              <a:t>name</a:t>
+            </a:r>
+            <a:r>
+              <a:rPr lang="de-DE" sz="1800" kern="0" dirty="0">
+                <a:latin typeface="Courier New" panose="02070309020205020404" pitchFamily="49" charset="0"/>
+                <a:ea typeface="Arial Unicode MS" pitchFamily="34" charset="-128"/>
+                <a:cs typeface="Courier New" panose="02070309020205020404" pitchFamily="49" charset="0"/>
+              </a:rPr>
+              <a:t>/ID </a:t>
+            </a:r>
+            <a:r>
+              <a:rPr lang="de-DE" sz="1800" kern="0" dirty="0" err="1">
+                <a:latin typeface="Courier New" panose="02070309020205020404" pitchFamily="49" charset="0"/>
+                <a:ea typeface="Arial Unicode MS" pitchFamily="34" charset="-128"/>
+                <a:cs typeface="Courier New" panose="02070309020205020404" pitchFamily="49" charset="0"/>
+              </a:rPr>
+              <a:t>of</a:t>
+            </a:r>
+            <a:r>
+              <a:rPr lang="de-DE" sz="1800" kern="0" dirty="0">
+                <a:latin typeface="Courier New" panose="02070309020205020404" pitchFamily="49" charset="0"/>
+                <a:ea typeface="Arial Unicode MS" pitchFamily="34" charset="-128"/>
+                <a:cs typeface="Courier New" panose="02070309020205020404" pitchFamily="49" charset="0"/>
+              </a:rPr>
+              <a:t> </a:t>
+            </a:r>
+            <a:r>
+              <a:rPr lang="de-DE" sz="1800" kern="0" dirty="0" err="1">
+                <a:latin typeface="Courier New" panose="02070309020205020404" pitchFamily="49" charset="0"/>
+                <a:ea typeface="Arial Unicode MS" pitchFamily="34" charset="-128"/>
+                <a:cs typeface="Courier New" panose="02070309020205020404" pitchFamily="49" charset="0"/>
+              </a:rPr>
+              <a:t>your</a:t>
+            </a:r>
+            <a:r>
+              <a:rPr lang="de-DE" sz="1800" kern="0" dirty="0">
+                <a:latin typeface="Courier New" panose="02070309020205020404" pitchFamily="49" charset="0"/>
+                <a:ea typeface="Arial Unicode MS" pitchFamily="34" charset="-128"/>
+                <a:cs typeface="Courier New" panose="02070309020205020404" pitchFamily="49" charset="0"/>
+              </a:rPr>
+              <a:t> </a:t>
+            </a:r>
+            <a:r>
+              <a:rPr lang="de-DE" sz="1800" kern="0" dirty="0" err="1">
+                <a:latin typeface="Courier New" panose="02070309020205020404" pitchFamily="49" charset="0"/>
+                <a:ea typeface="Arial Unicode MS" pitchFamily="34" charset="-128"/>
+                <a:cs typeface="Courier New" panose="02070309020205020404" pitchFamily="49" charset="0"/>
+              </a:rPr>
+              <a:t>container</a:t>
+            </a:r>
+            <a:r>
+              <a:rPr lang="de-DE" sz="1800" kern="0" dirty="0">
+                <a:latin typeface="Courier New" panose="02070309020205020404" pitchFamily="49" charset="0"/>
+                <a:ea typeface="Arial Unicode MS" pitchFamily="34" charset="-128"/>
+                <a:cs typeface="Courier New" panose="02070309020205020404" pitchFamily="49" charset="0"/>
+              </a:rPr>
+              <a:t>&gt;</a:t>
+            </a:r>
+          </a:p>
+          <a:p>
+            <a:pPr fontAlgn="base">
+              <a:lnSpc>
+                <a:spcPct val="150000"/>
+              </a:lnSpc>
+              <a:spcBef>
+                <a:spcPct val="50000"/>
+              </a:spcBef>
+              <a:spcAft>
+                <a:spcPct val="0"/>
+              </a:spcAft>
+              <a:buClr>
+                <a:srgbClr val="F0AB00"/>
+              </a:buClr>
+              <a:buSzPct val="80000"/>
+            </a:pPr>
+            <a:r>
+              <a:rPr lang="de-DE" sz="1800" kern="0" dirty="0">
+                <a:latin typeface="Courier New" panose="02070309020205020404" pitchFamily="49" charset="0"/>
+                <a:ea typeface="Arial Unicode MS" pitchFamily="34" charset="-128"/>
+                <a:cs typeface="Courier New" panose="02070309020205020404" pitchFamily="49" charset="0"/>
+              </a:rPr>
+              <a:t>	$: </a:t>
+            </a:r>
+            <a:r>
+              <a:rPr lang="de-DE" sz="1800" kern="0" dirty="0" err="1">
+                <a:latin typeface="Courier New" panose="02070309020205020404" pitchFamily="49" charset="0"/>
+                <a:ea typeface="Arial Unicode MS" pitchFamily="34" charset="-128"/>
+                <a:cs typeface="Courier New" panose="02070309020205020404" pitchFamily="49" charset="0"/>
+              </a:rPr>
+              <a:t>apt-get</a:t>
+            </a:r>
+            <a:r>
+              <a:rPr lang="de-DE" sz="1800" kern="0" dirty="0">
+                <a:latin typeface="Courier New" panose="02070309020205020404" pitchFamily="49" charset="0"/>
+                <a:ea typeface="Arial Unicode MS" pitchFamily="34" charset="-128"/>
+                <a:cs typeface="Courier New" panose="02070309020205020404" pitchFamily="49" charset="0"/>
+              </a:rPr>
+              <a:t> update</a:t>
+            </a:r>
+          </a:p>
+          <a:p>
+            <a:pPr fontAlgn="base">
+              <a:lnSpc>
+                <a:spcPct val="150000"/>
+              </a:lnSpc>
+              <a:spcBef>
+                <a:spcPct val="50000"/>
+              </a:spcBef>
+              <a:spcAft>
+                <a:spcPct val="0"/>
+              </a:spcAft>
+              <a:buClr>
+                <a:srgbClr val="F0AB00"/>
+              </a:buClr>
+              <a:buSzPct val="80000"/>
+            </a:pPr>
+            <a:r>
+              <a:rPr lang="de-DE" sz="1800" kern="0" dirty="0">
+                <a:latin typeface="Courier New" panose="02070309020205020404" pitchFamily="49" charset="0"/>
+                <a:ea typeface="Arial Unicode MS" pitchFamily="34" charset="-128"/>
+                <a:cs typeface="Courier New" panose="02070309020205020404" pitchFamily="49" charset="0"/>
+              </a:rPr>
+              <a:t>	$: </a:t>
+            </a:r>
+            <a:r>
+              <a:rPr lang="de-DE" sz="1800" kern="0" dirty="0" err="1">
+                <a:latin typeface="Courier New" panose="02070309020205020404" pitchFamily="49" charset="0"/>
+                <a:ea typeface="Arial Unicode MS" pitchFamily="34" charset="-128"/>
+                <a:cs typeface="Courier New" panose="02070309020205020404" pitchFamily="49" charset="0"/>
+              </a:rPr>
+              <a:t>apt-get</a:t>
+            </a:r>
+            <a:r>
+              <a:rPr lang="de-DE" sz="1800" kern="0" dirty="0">
+                <a:latin typeface="Courier New" panose="02070309020205020404" pitchFamily="49" charset="0"/>
+                <a:ea typeface="Arial Unicode MS" pitchFamily="34" charset="-128"/>
+                <a:cs typeface="Courier New" panose="02070309020205020404" pitchFamily="49" charset="0"/>
+              </a:rPr>
+              <a:t> </a:t>
+            </a:r>
+            <a:r>
+              <a:rPr lang="de-DE" sz="1800" kern="0" dirty="0" err="1">
+                <a:latin typeface="Courier New" panose="02070309020205020404" pitchFamily="49" charset="0"/>
+                <a:ea typeface="Arial Unicode MS" pitchFamily="34" charset="-128"/>
+                <a:cs typeface="Courier New" panose="02070309020205020404" pitchFamily="49" charset="0"/>
+              </a:rPr>
+              <a:t>install</a:t>
+            </a:r>
+            <a:r>
+              <a:rPr lang="de-DE" sz="1800" kern="0" dirty="0">
+                <a:latin typeface="Courier New" panose="02070309020205020404" pitchFamily="49" charset="0"/>
+                <a:ea typeface="Arial Unicode MS" pitchFamily="34" charset="-128"/>
+                <a:cs typeface="Courier New" panose="02070309020205020404" pitchFamily="49" charset="0"/>
+              </a:rPr>
+              <a:t> </a:t>
+            </a:r>
+            <a:r>
+              <a:rPr lang="de-DE" sz="1800" kern="0" dirty="0" err="1">
+                <a:latin typeface="Courier New" panose="02070309020205020404" pitchFamily="49" charset="0"/>
+                <a:ea typeface="Arial Unicode MS" pitchFamily="34" charset="-128"/>
+                <a:cs typeface="Courier New" panose="02070309020205020404" pitchFamily="49" charset="0"/>
+              </a:rPr>
+              <a:t>cowsay</a:t>
             </a:r>
             <a:endParaRPr lang="de-DE" sz="1800" kern="0" dirty="0">
               <a:latin typeface="Courier New" panose="02070309020205020404" pitchFamily="49" charset="0"/>
@@ -22983,7 +23254,7 @@
                 <a:ea typeface="Arial Unicode MS" pitchFamily="34" charset="-128"/>
                 <a:cs typeface="Courier New" panose="02070309020205020404" pitchFamily="49" charset="0"/>
               </a:rPr>
-              <a:t>$: </a:t>
+              <a:t>	$: cd /</a:t>
             </a:r>
             <a:r>
               <a:rPr lang="de-DE" sz="1800" kern="0" dirty="0" err="1">
@@ -22991,7 +23262,7 @@
                 <a:ea typeface="Arial Unicode MS" pitchFamily="34" charset="-128"/>
                 <a:cs typeface="Courier New" panose="02070309020205020404" pitchFamily="49" charset="0"/>
               </a:rPr>
-              <a:t>docker</a:t>
+              <a:t>usr</a:t>
             </a:r>
             <a:r>
               <a:rPr lang="de-DE" sz="1800" kern="0" dirty="0">
@@ -22999,7 +23270,7 @@
                 <a:ea typeface="Arial Unicode MS" pitchFamily="34" charset="-128"/>
                 <a:cs typeface="Courier New" panose="02070309020205020404" pitchFamily="49" charset="0"/>
               </a:rPr>
-              <a:t> </a:t>
+              <a:t>/</a:t>
             </a:r>
             <a:r>
               <a:rPr lang="de-DE" sz="1800" kern="0" dirty="0" err="1">
@@ -23007,7 +23278,7 @@
                 <a:ea typeface="Arial Unicode MS" pitchFamily="34" charset="-128"/>
                 <a:cs typeface="Courier New" panose="02070309020205020404" pitchFamily="49" charset="0"/>
               </a:rPr>
-              <a:t>container</a:t>
+              <a:t>games</a:t>
             </a:r>
             <a:r>
               <a:rPr lang="de-DE" sz="1800" kern="0" dirty="0">
@@ -23016,159 +23287,6 @@
                 <a:cs typeface="Courier New" panose="02070309020205020404" pitchFamily="49" charset="0"/>
               </a:rPr>
               <a:t> </a:t>
-            </a:r>
-            <a:r>
-              <a:rPr lang="de-DE" sz="1800" kern="0" dirty="0" err="1">
-                <a:latin typeface="Courier New" panose="02070309020205020404" pitchFamily="49" charset="0"/>
-                <a:ea typeface="Arial Unicode MS" pitchFamily="34" charset="-128"/>
-                <a:cs typeface="Courier New" panose="02070309020205020404" pitchFamily="49" charset="0"/>
-              </a:rPr>
-              <a:t>list</a:t>
-            </a:r>
-            <a:r>
-              <a:rPr lang="de-DE" sz="1800" kern="0" dirty="0">
-                <a:latin typeface="Courier New" panose="02070309020205020404" pitchFamily="49" charset="0"/>
-                <a:ea typeface="Arial Unicode MS" pitchFamily="34" charset="-128"/>
-                <a:cs typeface="Courier New" panose="02070309020205020404" pitchFamily="49" charset="0"/>
-              </a:rPr>
-              <a:t> –a</a:t>
-            </a:r>
-          </a:p>
-          <a:p>
-            <a:pPr fontAlgn="base">
-              <a:lnSpc>
-                <a:spcPct val="150000"/>
-              </a:lnSpc>
-              <a:spcBef>
-                <a:spcPct val="50000"/>
-              </a:spcBef>
-              <a:spcAft>
-                <a:spcPct val="0"/>
-              </a:spcAft>
-              <a:buClr>
-                <a:srgbClr val="F0AB00"/>
-              </a:buClr>
-              <a:buSzPct val="80000"/>
-            </a:pPr>
-            <a:r>
-              <a:rPr lang="de-DE" sz="1800" kern="0" dirty="0">
-                <a:latin typeface="Courier New" panose="02070309020205020404" pitchFamily="49" charset="0"/>
-                <a:ea typeface="Arial Unicode MS" pitchFamily="34" charset="-128"/>
-                <a:cs typeface="Courier New" panose="02070309020205020404" pitchFamily="49" charset="0"/>
-              </a:rPr>
-              <a:t>$: </a:t>
-            </a:r>
-            <a:r>
-              <a:rPr lang="de-DE" sz="1800" kern="0" dirty="0" err="1">
-                <a:latin typeface="Courier New" panose="02070309020205020404" pitchFamily="49" charset="0"/>
-                <a:ea typeface="Arial Unicode MS" pitchFamily="34" charset="-128"/>
-                <a:cs typeface="Courier New" panose="02070309020205020404" pitchFamily="49" charset="0"/>
-              </a:rPr>
-              <a:t>docker</a:t>
-            </a:r>
-            <a:r>
-              <a:rPr lang="de-DE" sz="1800" kern="0" dirty="0">
-                <a:latin typeface="Courier New" panose="02070309020205020404" pitchFamily="49" charset="0"/>
-                <a:ea typeface="Arial Unicode MS" pitchFamily="34" charset="-128"/>
-                <a:cs typeface="Courier New" panose="02070309020205020404" pitchFamily="49" charset="0"/>
-              </a:rPr>
-              <a:t> </a:t>
-            </a:r>
-            <a:r>
-              <a:rPr lang="de-DE" sz="1800" kern="0" dirty="0" err="1">
-                <a:latin typeface="Courier New" panose="02070309020205020404" pitchFamily="49" charset="0"/>
-                <a:ea typeface="Arial Unicode MS" pitchFamily="34" charset="-128"/>
-                <a:cs typeface="Courier New" panose="02070309020205020404" pitchFamily="49" charset="0"/>
-              </a:rPr>
-              <a:t>container</a:t>
-            </a:r>
-            <a:r>
-              <a:rPr lang="de-DE" sz="1800" kern="0" dirty="0">
-                <a:latin typeface="Courier New" panose="02070309020205020404" pitchFamily="49" charset="0"/>
-                <a:ea typeface="Arial Unicode MS" pitchFamily="34" charset="-128"/>
-                <a:cs typeface="Courier New" panose="02070309020205020404" pitchFamily="49" charset="0"/>
-              </a:rPr>
-              <a:t> </a:t>
-            </a:r>
-            <a:r>
-              <a:rPr lang="de-DE" sz="1800" kern="0" dirty="0" err="1">
-                <a:latin typeface="Courier New" panose="02070309020205020404" pitchFamily="49" charset="0"/>
-                <a:ea typeface="Arial Unicode MS" pitchFamily="34" charset="-128"/>
-                <a:cs typeface="Courier New" panose="02070309020205020404" pitchFamily="49" charset="0"/>
-              </a:rPr>
-              <a:t>start</a:t>
-            </a:r>
-            <a:r>
-              <a:rPr lang="de-DE" sz="1800" kern="0" dirty="0">
-                <a:latin typeface="Courier New" panose="02070309020205020404" pitchFamily="49" charset="0"/>
-                <a:ea typeface="Arial Unicode MS" pitchFamily="34" charset="-128"/>
-                <a:cs typeface="Courier New" panose="02070309020205020404" pitchFamily="49" charset="0"/>
-              </a:rPr>
-              <a:t> –i &lt;</a:t>
-            </a:r>
-            <a:r>
-              <a:rPr lang="de-DE" sz="1800" kern="0" dirty="0" err="1">
-                <a:latin typeface="Courier New" panose="02070309020205020404" pitchFamily="49" charset="0"/>
-                <a:ea typeface="Arial Unicode MS" pitchFamily="34" charset="-128"/>
-                <a:cs typeface="Courier New" panose="02070309020205020404" pitchFamily="49" charset="0"/>
-              </a:rPr>
-              <a:t>name</a:t>
-            </a:r>
-            <a:r>
-              <a:rPr lang="de-DE" sz="1800" kern="0" dirty="0">
-                <a:latin typeface="Courier New" panose="02070309020205020404" pitchFamily="49" charset="0"/>
-                <a:ea typeface="Arial Unicode MS" pitchFamily="34" charset="-128"/>
-                <a:cs typeface="Courier New" panose="02070309020205020404" pitchFamily="49" charset="0"/>
-              </a:rPr>
-              <a:t>/ID </a:t>
-            </a:r>
-            <a:r>
-              <a:rPr lang="de-DE" sz="1800" kern="0" dirty="0" err="1">
-                <a:latin typeface="Courier New" panose="02070309020205020404" pitchFamily="49" charset="0"/>
-                <a:ea typeface="Arial Unicode MS" pitchFamily="34" charset="-128"/>
-                <a:cs typeface="Courier New" panose="02070309020205020404" pitchFamily="49" charset="0"/>
-              </a:rPr>
-              <a:t>of</a:t>
-            </a:r>
-            <a:r>
-              <a:rPr lang="de-DE" sz="1800" kern="0" dirty="0">
-                <a:latin typeface="Courier New" panose="02070309020205020404" pitchFamily="49" charset="0"/>
-                <a:ea typeface="Arial Unicode MS" pitchFamily="34" charset="-128"/>
-                <a:cs typeface="Courier New" panose="02070309020205020404" pitchFamily="49" charset="0"/>
-              </a:rPr>
-              <a:t> </a:t>
-            </a:r>
-            <a:r>
-              <a:rPr lang="de-DE" sz="1800" kern="0" dirty="0" err="1">
-                <a:latin typeface="Courier New" panose="02070309020205020404" pitchFamily="49" charset="0"/>
-                <a:ea typeface="Arial Unicode MS" pitchFamily="34" charset="-128"/>
-                <a:cs typeface="Courier New" panose="02070309020205020404" pitchFamily="49" charset="0"/>
-              </a:rPr>
-              <a:t>your</a:t>
-            </a:r>
-            <a:r>
-              <a:rPr lang="de-DE" sz="1800" kern="0" dirty="0">
-                <a:latin typeface="Courier New" panose="02070309020205020404" pitchFamily="49" charset="0"/>
-                <a:ea typeface="Arial Unicode MS" pitchFamily="34" charset="-128"/>
-                <a:cs typeface="Courier New" panose="02070309020205020404" pitchFamily="49" charset="0"/>
-              </a:rPr>
-              <a:t> </a:t>
-            </a:r>
-            <a:r>
-              <a:rPr lang="de-DE" sz="1800" kern="0" dirty="0" err="1">
-                <a:latin typeface="Courier New" panose="02070309020205020404" pitchFamily="49" charset="0"/>
-                <a:ea typeface="Arial Unicode MS" pitchFamily="34" charset="-128"/>
-                <a:cs typeface="Courier New" panose="02070309020205020404" pitchFamily="49" charset="0"/>
-              </a:rPr>
-              <a:t>container</a:t>
-            </a:r>
-            <a:r>
-              <a:rPr lang="de-DE" sz="1800" kern="0" dirty="0">
-                <a:latin typeface="Courier New" panose="02070309020205020404" pitchFamily="49" charset="0"/>
-                <a:ea typeface="Arial Unicode MS" pitchFamily="34" charset="-128"/>
-                <a:cs typeface="Courier New" panose="02070309020205020404" pitchFamily="49" charset="0"/>
-              </a:rPr>
-              <a:t>&gt;</a:t>
             </a:r>
           </a:p>
           <a:p>
@@ -23279,85 +23397,12 @@
               <a:cs typeface="Courier New" panose="02070309020205020404" pitchFamily="49" charset="0"/>
             </a:endParaRPr>
           </a:p>
-          <a:p>
-            <a:pPr fontAlgn="base">
-              <a:lnSpc>
-                <a:spcPct val="150000"/>
-              </a:lnSpc>
-              <a:spcBef>
-                <a:spcPct val="50000"/>
-              </a:spcBef>
-              <a:spcAft>
-                <a:spcPct val="0"/>
-              </a:spcAft>
-              <a:buClr>
-                <a:srgbClr val="F0AB00"/>
-              </a:buClr>
-              <a:buSzPct val="80000"/>
-            </a:pPr>
-            <a:r>
-              <a:rPr lang="de-DE" sz="1800" kern="0" dirty="0">
-                <a:latin typeface="Courier New" panose="02070309020205020404" pitchFamily="49" charset="0"/>
-                <a:ea typeface="Arial Unicode MS" pitchFamily="34" charset="-128"/>
-                <a:cs typeface="Courier New" panose="02070309020205020404" pitchFamily="49" charset="0"/>
-              </a:rPr>
-              <a:t>$: </a:t>
-            </a:r>
-            <a:r>
-              <a:rPr lang="de-DE" sz="1800" kern="0" dirty="0" err="1">
-                <a:latin typeface="Courier New" panose="02070309020205020404" pitchFamily="49" charset="0"/>
-                <a:ea typeface="Arial Unicode MS" pitchFamily="34" charset="-128"/>
-                <a:cs typeface="Courier New" panose="02070309020205020404" pitchFamily="49" charset="0"/>
-              </a:rPr>
-              <a:t>docker</a:t>
-            </a:r>
-            <a:r>
-              <a:rPr lang="de-DE" sz="1800" kern="0" dirty="0">
-                <a:latin typeface="Courier New" panose="02070309020205020404" pitchFamily="49" charset="0"/>
-                <a:ea typeface="Arial Unicode MS" pitchFamily="34" charset="-128"/>
-                <a:cs typeface="Courier New" panose="02070309020205020404" pitchFamily="49" charset="0"/>
-              </a:rPr>
-              <a:t> </a:t>
-            </a:r>
-            <a:r>
-              <a:rPr lang="de-DE" sz="1800" kern="0" dirty="0" err="1">
-                <a:latin typeface="Courier New" panose="02070309020205020404" pitchFamily="49" charset="0"/>
-                <a:ea typeface="Arial Unicode MS" pitchFamily="34" charset="-128"/>
-                <a:cs typeface="Courier New" panose="02070309020205020404" pitchFamily="49" charset="0"/>
-              </a:rPr>
-              <a:t>container</a:t>
-            </a:r>
-            <a:r>
-              <a:rPr lang="de-DE" sz="1800" kern="0" dirty="0">
-                <a:latin typeface="Courier New" panose="02070309020205020404" pitchFamily="49" charset="0"/>
-                <a:ea typeface="Arial Unicode MS" pitchFamily="34" charset="-128"/>
-                <a:cs typeface="Courier New" panose="02070309020205020404" pitchFamily="49" charset="0"/>
-              </a:rPr>
-              <a:t> </a:t>
-            </a:r>
-            <a:r>
-              <a:rPr lang="de-DE" sz="1800" kern="0" dirty="0" err="1">
-                <a:latin typeface="Courier New" panose="02070309020205020404" pitchFamily="49" charset="0"/>
-                <a:ea typeface="Arial Unicode MS" pitchFamily="34" charset="-128"/>
-                <a:cs typeface="Courier New" panose="02070309020205020404" pitchFamily="49" charset="0"/>
-              </a:rPr>
-              <a:t>list</a:t>
-            </a:r>
-            <a:r>
-              <a:rPr lang="de-DE" sz="1800" kern="0" dirty="0">
-                <a:latin typeface="Courier New" panose="02070309020205020404" pitchFamily="49" charset="0"/>
-                <a:ea typeface="Arial Unicode MS" pitchFamily="34" charset="-128"/>
-                <a:cs typeface="Courier New" panose="02070309020205020404" pitchFamily="49" charset="0"/>
-              </a:rPr>
-              <a:t> -a</a:t>
-            </a:r>
-          </a:p>
         </p:txBody>
       </p:sp>
     </p:spTree>
     <p:extLst>
       <p:ext uri="{BB962C8B-B14F-4D97-AF65-F5344CB8AC3E}">
-        <p14:creationId xmlns:p14="http://schemas.microsoft.com/office/powerpoint/2010/main" val="1257255272"/>
+        <p14:creationId xmlns:p14="http://schemas.microsoft.com/office/powerpoint/2010/main" val="4006759392"/>
       </p:ext>
     </p:extLst>
   </p:cSld>
@@ -23426,10 +23471,10 @@
       </p:sp>
       <p:sp>
         <p:nvSpPr>
-          <p:cNvPr id="3" name="Textfeld 2">
+          <p:cNvPr id="4" name="Textfeld 2">
             <a:extLst>
               <a:ext uri="{FF2B5EF4-FFF2-40B4-BE49-F238E27FC236}">
-                <a16:creationId xmlns:a16="http://schemas.microsoft.com/office/drawing/2014/main" id="{3796437A-8539-847E-5ABD-D965AB464BBD}"/>
+                <a16:creationId xmlns:a16="http://schemas.microsoft.com/office/drawing/2014/main" id="{DB6C8179-3E98-8005-BD07-ED64C3FE8905}"/>
               </a:ext>
             </a:extLst>
           </p:cNvPr>
@@ -23438,8 +23483,8 @@
         </p:nvSpPr>
         <p:spPr>
           <a:xfrm>
-            <a:off x="504001" y="1576570"/>
-            <a:ext cx="8667708" cy="3704860"/>
+            <a:off x="504001" y="1109134"/>
+            <a:ext cx="8667708" cy="2596865"/>
           </a:xfrm>
           <a:prstGeom prst="rect">
             <a:avLst/>
@@ -23489,7 +23534,7 @@
                 <a:ea typeface="Arial Unicode MS" pitchFamily="34" charset="-128"/>
                 <a:cs typeface="Courier New" panose="02070309020205020404" pitchFamily="49" charset="0"/>
               </a:rPr>
-              <a:t> pull </a:t>
+              <a:t> </a:t>
             </a:r>
             <a:r>
               <a:rPr lang="de-DE" sz="1800" kern="0" dirty="0" err="1">
@@ -23497,13 +23542,32 @@
                 <a:ea typeface="Arial Unicode MS" pitchFamily="34" charset="-128"/>
                 <a:cs typeface="Courier New" panose="02070309020205020404" pitchFamily="49" charset="0"/>
               </a:rPr>
-              <a:t>nginx:latest</a:t>
-            </a:r>
-            <a:endParaRPr lang="de-DE" sz="1800" kern="0" dirty="0">
-              <a:latin typeface="Courier New" panose="02070309020205020404" pitchFamily="49" charset="0"/>
-              <a:ea typeface="Arial Unicode MS" pitchFamily="34" charset="-128"/>
-              <a:cs typeface="Courier New" panose="02070309020205020404" pitchFamily="49" charset="0"/>
-            </a:endParaRPr>
+              <a:t>container</a:t>
+            </a:r>
+            <a:r>
+              <a:rPr lang="de-DE" sz="1800" kern="0" dirty="0">
+                <a:latin typeface="Courier New" panose="02070309020205020404" pitchFamily="49" charset="0"/>
+                <a:ea typeface="Arial Unicode MS" pitchFamily="34" charset="-128"/>
+                <a:cs typeface="Courier New" panose="02070309020205020404" pitchFamily="49" charset="0"/>
+              </a:rPr>
+              <a:t> </a:t>
+            </a:r>
+            <a:r>
+              <a:rPr lang="de-DE" sz="1800" kern="0" dirty="0" err="1">
+                <a:latin typeface="Courier New" panose="02070309020205020404" pitchFamily="49" charset="0"/>
+                <a:ea typeface="Arial Unicode MS" pitchFamily="34" charset="-128"/>
+                <a:cs typeface="Courier New" panose="02070309020205020404" pitchFamily="49" charset="0"/>
+              </a:rPr>
+              <a:t>list</a:t>
+            </a:r>
+            <a:r>
+              <a:rPr lang="de-DE" sz="1800" kern="0" dirty="0">
+                <a:latin typeface="Courier New" panose="02070309020205020404" pitchFamily="49" charset="0"/>
+                <a:ea typeface="Arial Unicode MS" pitchFamily="34" charset="-128"/>
+                <a:cs typeface="Courier New" panose="02070309020205020404" pitchFamily="49" charset="0"/>
+              </a:rPr>
+              <a:t> –a</a:t>
+            </a:r>
           </a:p>
           <a:p>
             <a:pPr fontAlgn="base">
@@ -23551,7 +23615,7 @@
                 <a:ea typeface="Arial Unicode MS" pitchFamily="34" charset="-128"/>
                 <a:cs typeface="Courier New" panose="02070309020205020404" pitchFamily="49" charset="0"/>
               </a:rPr>
-              <a:t>create</a:t>
+              <a:t>container</a:t>
             </a:r>
             <a:r>
               <a:rPr lang="de-DE" sz="1800" kern="0" dirty="0">
@@ -23567,37 +23631,15 @@
                 <a:ea typeface="Arial Unicode MS" pitchFamily="34" charset="-128"/>
                 <a:cs typeface="Courier New" panose="02070309020205020404" pitchFamily="49" charset="0"/>
               </a:rPr>
-              <a:t>nginx:latest</a:t>
-            </a:r>
-            <a:endParaRPr lang="de-DE" sz="1800" kern="0" dirty="0">
-              <a:latin typeface="Courier New" panose="02070309020205020404" pitchFamily="49" charset="0"/>
-              <a:ea typeface="Arial Unicode MS" pitchFamily="34" charset="-128"/>
-              <a:cs typeface="Courier New" panose="02070309020205020404" pitchFamily="49" charset="0"/>
-            </a:endParaRPr>
-          </a:p>
-          <a:p>
-            <a:pPr fontAlgn="base">
-              <a:lnSpc>
-                <a:spcPct val="150000"/>
-              </a:lnSpc>
-              <a:spcBef>
-                <a:spcPct val="50000"/>
-              </a:spcBef>
-              <a:spcAft>
-                <a:spcPct val="0"/>
-              </a:spcAft>
-              <a:buClr>
-                <a:srgbClr val="F0AB00"/>
-              </a:buClr>
-              <a:buSzPct val="80000"/>
-            </a:pPr>
+              <a:t>start</a:t>
+            </a:r>
             <a:r>
               <a:rPr lang="de-DE" sz="1800" kern="0" dirty="0">
                 <a:latin typeface="Courier New" panose="02070309020205020404" pitchFamily="49" charset="0"/>
                 <a:ea typeface="Arial Unicode MS" pitchFamily="34" charset="-128"/>
                 <a:cs typeface="Courier New" panose="02070309020205020404" pitchFamily="49" charset="0"/>
               </a:rPr>
-              <a:t>$: </a:t>
+              <a:t> &lt;ID/</a:t>
             </a:r>
             <a:r>
               <a:rPr lang="de-DE" sz="1800" kern="0" dirty="0" err="1">
@@ -23605,7 +23647,7 @@
                 <a:ea typeface="Arial Unicode MS" pitchFamily="34" charset="-128"/>
                 <a:cs typeface="Courier New" panose="02070309020205020404" pitchFamily="49" charset="0"/>
               </a:rPr>
-              <a:t>docker</a:t>
+              <a:t>name</a:t>
             </a:r>
             <a:r>
               <a:rPr lang="de-DE" sz="1800" kern="0" dirty="0">
@@ -23621,7 +23663,7 @@
                 <a:ea typeface="Arial Unicode MS" pitchFamily="34" charset="-128"/>
                 <a:cs typeface="Courier New" panose="02070309020205020404" pitchFamily="49" charset="0"/>
               </a:rPr>
-              <a:t>start</a:t>
+              <a:t>of</a:t>
             </a:r>
             <a:r>
               <a:rPr lang="de-DE" sz="1800" kern="0" dirty="0">
@@ -23629,7 +23671,7 @@
                 <a:ea typeface="Arial Unicode MS" pitchFamily="34" charset="-128"/>
                 <a:cs typeface="Courier New" panose="02070309020205020404" pitchFamily="49" charset="0"/>
               </a:rPr>
-              <a:t> &lt;ID </a:t>
+              <a:t> </a:t>
             </a:r>
             <a:r>
               <a:rPr lang="de-DE" sz="1800" kern="0" dirty="0" err="1">
@@ -23637,7 +23679,7 @@
                 <a:ea typeface="Arial Unicode MS" pitchFamily="34" charset="-128"/>
                 <a:cs typeface="Courier New" panose="02070309020205020404" pitchFamily="49" charset="0"/>
               </a:rPr>
-              <a:t>of</a:t>
+              <a:t>your</a:t>
             </a:r>
             <a:r>
               <a:rPr lang="de-DE" sz="1800" kern="0" dirty="0">
@@ -23653,7 +23695,7 @@
                 <a:ea typeface="Arial Unicode MS" pitchFamily="34" charset="-128"/>
                 <a:cs typeface="Courier New" panose="02070309020205020404" pitchFamily="49" charset="0"/>
               </a:rPr>
-              <a:t>your</a:t>
+              <a:t>container</a:t>
             </a:r>
             <a:r>
               <a:rPr lang="de-DE" sz="1800" kern="0" dirty="0">
@@ -23661,96 +23703,7 @@
                 <a:ea typeface="Arial Unicode MS" pitchFamily="34" charset="-128"/>
                 <a:cs typeface="Courier New" panose="02070309020205020404" pitchFamily="49" charset="0"/>
               </a:rPr>
-              <a:t> </a:t>
-            </a:r>
-            <a:r>
-              <a:rPr lang="de-DE" sz="1800" kern="0" dirty="0" err="1">
-                <a:latin typeface="Courier New" panose="02070309020205020404" pitchFamily="49" charset="0"/>
-                <a:ea typeface="Arial Unicode MS" pitchFamily="34" charset="-128"/>
-                <a:cs typeface="Courier New" panose="02070309020205020404" pitchFamily="49" charset="0"/>
-              </a:rPr>
-              <a:t>container</a:t>
-            </a:r>
-            <a:r>
-              <a:rPr lang="de-DE" sz="1800" kern="0" dirty="0">
-                <a:latin typeface="Courier New" panose="02070309020205020404" pitchFamily="49" charset="0"/>
-                <a:ea typeface="Arial Unicode MS" pitchFamily="34" charset="-128"/>
-                <a:cs typeface="Courier New" panose="02070309020205020404" pitchFamily="49" charset="0"/>
-              </a:rPr>
               <a:t>&gt;</a:t>
-            </a:r>
-          </a:p>
-          <a:p>
-            <a:pPr fontAlgn="base">
-              <a:lnSpc>
-                <a:spcPct val="150000"/>
-              </a:lnSpc>
-              <a:spcBef>
-                <a:spcPct val="50000"/>
-              </a:spcBef>
-              <a:spcAft>
-                <a:spcPct val="0"/>
-              </a:spcAft>
-              <a:buClr>
-                <a:srgbClr val="F0AB00"/>
-              </a:buClr>
-              <a:buSzPct val="80000"/>
-            </a:pPr>
-            <a:r>
-              <a:rPr lang="de-DE" sz="1800" kern="0" dirty="0">
-                <a:latin typeface="Courier New" panose="02070309020205020404" pitchFamily="49" charset="0"/>
-                <a:ea typeface="Arial Unicode MS" pitchFamily="34" charset="-128"/>
-                <a:cs typeface="Courier New" panose="02070309020205020404" pitchFamily="49" charset="0"/>
-              </a:rPr>
-              <a:t>$: </a:t>
-            </a:r>
-            <a:r>
-              <a:rPr lang="de-DE" sz="1800" kern="0" dirty="0" err="1">
-                <a:latin typeface="Courier New" panose="02070309020205020404" pitchFamily="49" charset="0"/>
-                <a:ea typeface="Arial Unicode MS" pitchFamily="34" charset="-128"/>
-                <a:cs typeface="Courier New" panose="02070309020205020404" pitchFamily="49" charset="0"/>
-              </a:rPr>
-              <a:t>docker</a:t>
-            </a:r>
-            <a:r>
-              <a:rPr lang="de-DE" sz="1800" kern="0" dirty="0">
-                <a:latin typeface="Courier New" panose="02070309020205020404" pitchFamily="49" charset="0"/>
-                <a:ea typeface="Arial Unicode MS" pitchFamily="34" charset="-128"/>
-                <a:cs typeface="Courier New" panose="02070309020205020404" pitchFamily="49" charset="0"/>
-              </a:rPr>
-              <a:t> </a:t>
-            </a:r>
-            <a:r>
-              <a:rPr lang="de-DE" sz="1800" kern="0" dirty="0" err="1">
-                <a:latin typeface="Courier New" panose="02070309020205020404" pitchFamily="49" charset="0"/>
-                <a:ea typeface="Arial Unicode MS" pitchFamily="34" charset="-128"/>
-                <a:cs typeface="Courier New" panose="02070309020205020404" pitchFamily="49" charset="0"/>
-              </a:rPr>
-              <a:t>container</a:t>
-            </a:r>
-            <a:r>
-              <a:rPr lang="de-DE" sz="1800" kern="0" dirty="0">
-                <a:latin typeface="Courier New" panose="02070309020205020404" pitchFamily="49" charset="0"/>
-                <a:ea typeface="Arial Unicode MS" pitchFamily="34" charset="-128"/>
-                <a:cs typeface="Courier New" panose="02070309020205020404" pitchFamily="49" charset="0"/>
-              </a:rPr>
-              <a:t> </a:t>
-            </a:r>
-            <a:r>
-              <a:rPr lang="de-DE" sz="1800" kern="0" dirty="0" err="1">
-                <a:latin typeface="Courier New" panose="02070309020205020404" pitchFamily="49" charset="0"/>
-                <a:ea typeface="Arial Unicode MS" pitchFamily="34" charset="-128"/>
-                <a:cs typeface="Courier New" panose="02070309020205020404" pitchFamily="49" charset="0"/>
-              </a:rPr>
-              <a:t>list</a:t>
-            </a:r>
-            <a:r>
-              <a:rPr lang="de-DE" sz="1800" kern="0" dirty="0">
-                <a:latin typeface="Courier New" panose="02070309020205020404" pitchFamily="49" charset="0"/>
-                <a:ea typeface="Arial Unicode MS" pitchFamily="34" charset="-128"/>
-                <a:cs typeface="Courier New" panose="02070309020205020404" pitchFamily="49" charset="0"/>
-              </a:rPr>
-              <a:t> –a</a:t>
             </a:r>
           </a:p>
           <a:p>
@@ -24126,10 +24079,10 @@
       </p:sp>
       <p:sp>
         <p:nvSpPr>
-          <p:cNvPr id="3" name="Textfeld 2">
+          <p:cNvPr id="4" name="Textfeld 2">
             <a:extLst>
               <a:ext uri="{FF2B5EF4-FFF2-40B4-BE49-F238E27FC236}">
-                <a16:creationId xmlns:a16="http://schemas.microsoft.com/office/drawing/2014/main" id="{3796437A-8539-847E-5ABD-D965AB464BBD}"/>
+                <a16:creationId xmlns:a16="http://schemas.microsoft.com/office/drawing/2014/main" id="{6CB831BA-F0EB-9384-22ED-D12081B7044F}"/>
               </a:ext>
             </a:extLst>
           </p:cNvPr>
@@ -24138,8 +24091,8 @@
         </p:nvSpPr>
         <p:spPr>
           <a:xfrm>
-            <a:off x="504001" y="2625383"/>
-            <a:ext cx="8667708" cy="2595903"/>
+            <a:off x="504001" y="1387094"/>
+            <a:ext cx="8667708" cy="2041906"/>
           </a:xfrm>
           <a:prstGeom prst="rect">
             <a:avLst/>
@@ -24206,111 +24159,6 @@
                 <a:cs typeface="Courier New" panose="02070309020205020404" pitchFamily="49" charset="0"/>
               </a:rPr>
               <a:t> &lt;ID/</a:t>
-            </a:r>
-            <a:r>
-              <a:rPr lang="de-DE" sz="1800" kern="0" dirty="0" err="1">
-                <a:latin typeface="Courier New" panose="02070309020205020404" pitchFamily="49" charset="0"/>
-                <a:ea typeface="Arial Unicode MS" pitchFamily="34" charset="-128"/>
-                <a:cs typeface="Courier New" panose="02070309020205020404" pitchFamily="49" charset="0"/>
-              </a:rPr>
-              <a:t>name</a:t>
-            </a:r>
-            <a:r>
-              <a:rPr lang="de-DE" sz="1800" kern="0" dirty="0">
-                <a:latin typeface="Courier New" panose="02070309020205020404" pitchFamily="49" charset="0"/>
-                <a:ea typeface="Arial Unicode MS" pitchFamily="34" charset="-128"/>
-                <a:cs typeface="Courier New" panose="02070309020205020404" pitchFamily="49" charset="0"/>
-              </a:rPr>
-              <a:t> </a:t>
-            </a:r>
-            <a:r>
-              <a:rPr lang="de-DE" sz="1800" kern="0" dirty="0" err="1">
-                <a:latin typeface="Courier New" panose="02070309020205020404" pitchFamily="49" charset="0"/>
-                <a:ea typeface="Arial Unicode MS" pitchFamily="34" charset="-128"/>
-                <a:cs typeface="Courier New" panose="02070309020205020404" pitchFamily="49" charset="0"/>
-              </a:rPr>
-              <a:t>of</a:t>
-            </a:r>
-            <a:r>
-              <a:rPr lang="de-DE" sz="1800" kern="0" dirty="0">
-                <a:latin typeface="Courier New" panose="02070309020205020404" pitchFamily="49" charset="0"/>
-                <a:ea typeface="Arial Unicode MS" pitchFamily="34" charset="-128"/>
-                <a:cs typeface="Courier New" panose="02070309020205020404" pitchFamily="49" charset="0"/>
-              </a:rPr>
-              <a:t> </a:t>
-            </a:r>
-            <a:r>
-              <a:rPr lang="de-DE" sz="1800" kern="0" dirty="0" err="1">
-                <a:latin typeface="Courier New" panose="02070309020205020404" pitchFamily="49" charset="0"/>
-                <a:ea typeface="Arial Unicode MS" pitchFamily="34" charset="-128"/>
-                <a:cs typeface="Courier New" panose="02070309020205020404" pitchFamily="49" charset="0"/>
-              </a:rPr>
-              <a:t>your</a:t>
-            </a:r>
-            <a:r>
-              <a:rPr lang="de-DE" sz="1800" kern="0" dirty="0">
-                <a:latin typeface="Courier New" panose="02070309020205020404" pitchFamily="49" charset="0"/>
-                <a:ea typeface="Arial Unicode MS" pitchFamily="34" charset="-128"/>
-                <a:cs typeface="Courier New" panose="02070309020205020404" pitchFamily="49" charset="0"/>
-              </a:rPr>
-              <a:t> </a:t>
-            </a:r>
-            <a:r>
-              <a:rPr lang="de-DE" sz="1800" kern="0" dirty="0" err="1">
-                <a:latin typeface="Courier New" panose="02070309020205020404" pitchFamily="49" charset="0"/>
-                <a:ea typeface="Arial Unicode MS" pitchFamily="34" charset="-128"/>
-                <a:cs typeface="Courier New" panose="02070309020205020404" pitchFamily="49" charset="0"/>
-              </a:rPr>
-              <a:t>container</a:t>
-            </a:r>
-            <a:r>
-              <a:rPr lang="de-DE" sz="1800" kern="0" dirty="0">
-                <a:latin typeface="Courier New" panose="02070309020205020404" pitchFamily="49" charset="0"/>
-                <a:ea typeface="Arial Unicode MS" pitchFamily="34" charset="-128"/>
-                <a:cs typeface="Courier New" panose="02070309020205020404" pitchFamily="49" charset="0"/>
-              </a:rPr>
-              <a:t>&gt;</a:t>
-            </a:r>
-          </a:p>
-          <a:p>
-            <a:pPr fontAlgn="base">
-              <a:lnSpc>
-                <a:spcPct val="150000"/>
-              </a:lnSpc>
-              <a:spcBef>
-                <a:spcPct val="50000"/>
-              </a:spcBef>
-              <a:spcAft>
-                <a:spcPct val="0"/>
-              </a:spcAft>
-              <a:buClr>
-                <a:srgbClr val="F0AB00"/>
-              </a:buClr>
-              <a:buSzPct val="80000"/>
-            </a:pPr>
-            <a:r>
-              <a:rPr lang="de-DE" sz="1800" kern="0" dirty="0">
-                <a:latin typeface="Courier New" panose="02070309020205020404" pitchFamily="49" charset="0"/>
-                <a:ea typeface="Arial Unicode MS" pitchFamily="34" charset="-128"/>
-                <a:cs typeface="Courier New" panose="02070309020205020404" pitchFamily="49" charset="0"/>
-              </a:rPr>
-              <a:t>$: </a:t>
-            </a:r>
-            <a:r>
-              <a:rPr lang="de-DE" sz="1800" kern="0" dirty="0" err="1">
-                <a:latin typeface="Courier New" panose="02070309020205020404" pitchFamily="49" charset="0"/>
-                <a:ea typeface="Arial Unicode MS" pitchFamily="34" charset="-128"/>
-                <a:cs typeface="Courier New" panose="02070309020205020404" pitchFamily="49" charset="0"/>
-              </a:rPr>
-              <a:t>docker</a:t>
-            </a:r>
-            <a:r>
-              <a:rPr lang="de-DE" sz="1800" kern="0" dirty="0">
-                <a:latin typeface="Courier New" panose="02070309020205020404" pitchFamily="49" charset="0"/>
-                <a:ea typeface="Arial Unicode MS" pitchFamily="34" charset="-128"/>
-                <a:cs typeface="Courier New" panose="02070309020205020404" pitchFamily="49" charset="0"/>
-              </a:rPr>
-              <a:t> logs &lt;ID/</a:t>
             </a:r>
             <a:r>
               <a:rPr lang="de-DE" sz="1800" kern="0" dirty="0" err="1">
@@ -27109,6 +26957,10 @@
               <a:rPr lang="de-DE" dirty="0" err="1"/>
               <a:t>along</a:t>
             </a:r>
+            <a:r>
+              <a:rPr lang="de-DE"/>
+              <a:t> (4)</a:t>
+            </a:r>
             <a:endParaRPr lang="de-DE" dirty="0"/>
           </a:p>
         </p:txBody>
@@ -27665,7 +27517,7 @@
     </p:spTree>
     <p:extLst>
       <p:ext uri="{BB962C8B-B14F-4D97-AF65-F5344CB8AC3E}">
-        <p14:creationId xmlns:p14="http://schemas.microsoft.com/office/powerpoint/2010/main" val="798876502"/>
+        <p14:creationId xmlns:p14="http://schemas.microsoft.com/office/powerpoint/2010/main" val="3895770100"/>
       </p:ext>
     </p:extLst>
   </p:cSld>
@@ -28338,6 +28190,12 @@
 </file>
 
 <file path=customXml/item1.xml><?xml version="1.0" encoding="utf-8"?>
+<p:properties xmlns:p="http://schemas.microsoft.com/office/2006/metadata/properties" xmlns:xsi="http://www.w3.org/2001/XMLSchema-instance" xmlns:pc="http://schemas.microsoft.com/office/infopath/2007/PartnerControls">
+  <documentManagement/>
+</p:properties>
+</file>
+
+<file path=customXml/item2.xml><?xml version="1.0" encoding="utf-8"?>
 <ct:contentTypeSchema xmlns:ct="http://schemas.microsoft.com/office/2006/metadata/contentType" xmlns:ma="http://schemas.microsoft.com/office/2006/metadata/properties/metaAttributes" ct:_="" ma:_="" ma:contentTypeName="Document" ma:contentTypeID="0x010100413C8A4F00697141B6FA960F762861E8" ma:contentTypeVersion="7" ma:contentTypeDescription="Create a new document." ma:contentTypeScope="" ma:versionID="75679eb20af3838b1eab1fbe72fef032">
   <xsd:schema xmlns:xsd="http://www.w3.org/2001/XMLSchema" xmlns:xs="http://www.w3.org/2001/XMLSchema" xmlns:p="http://schemas.microsoft.com/office/2006/metadata/properties" xmlns:ns3="49a59b68-094c-48f7-af2b-0072ac24b77e" targetNamespace="http://schemas.microsoft.com/office/2006/metadata/properties" ma:root="true" ma:fieldsID="223f61b356e47f140bcb594d278c0c55" ns3:_="">
     <xsd:import namespace="49a59b68-094c-48f7-af2b-0072ac24b77e"/>
@@ -28501,12 +28359,6 @@
 </ct:contentTypeSchema>
 </file>
 
-<file path=customXml/item2.xml><?xml version="1.0" encoding="utf-8"?>
-<p:properties xmlns:p="http://schemas.microsoft.com/office/2006/metadata/properties" xmlns:xsi="http://www.w3.org/2001/XMLSchema-instance" xmlns:pc="http://schemas.microsoft.com/office/infopath/2007/PartnerControls">
-  <documentManagement/>
-</p:properties>
-</file>
-
 <file path=customXml/item3.xml><?xml version="1.0" encoding="utf-8"?>
 <?mso-contentType ?>
 <FormTemplates xmlns="http://schemas.microsoft.com/sharepoint/v3/contenttype/forms">
@@ -28517,6 +28369,22 @@
 </file>
 
 <file path=customXml/itemProps1.xml><?xml version="1.0" encoding="utf-8"?>
+<ds:datastoreItem xmlns:ds="http://schemas.openxmlformats.org/officeDocument/2006/customXml" ds:itemID="{EE15B31B-466C-488E-B171-800C9BAA728E}">
+  <ds:schemaRefs>
+    <ds:schemaRef ds:uri="http://schemas.microsoft.com/office/2006/metadata/properties"/>
+    <ds:schemaRef ds:uri="http://schemas.microsoft.com/office/2006/documentManagement/types"/>
+    <ds:schemaRef ds:uri="http://purl.org/dc/elements/1.1/"/>
+    <ds:schemaRef ds:uri="49a59b68-094c-48f7-af2b-0072ac24b77e"/>
+    <ds:schemaRef ds:uri="http://schemas.microsoft.com/office/infopath/2007/PartnerControls"/>
+    <ds:schemaRef ds:uri="http://purl.org/dc/terms/"/>
+    <ds:schemaRef ds:uri="http://www.w3.org/XML/1998/namespace"/>
+    <ds:schemaRef ds:uri="http://schemas.openxmlformats.org/package/2006/metadata/core-properties"/>
+    <ds:schemaRef ds:uri="http://purl.org/dc/dcmitype/"/>
+  </ds:schemaRefs>
+</ds:datastoreItem>
+</file>
+
+<file path=customXml/itemProps2.xml><?xml version="1.0" encoding="utf-8"?>
 <ds:datastoreItem xmlns:ds="http://schemas.openxmlformats.org/officeDocument/2006/customXml" ds:itemID="{9234AC07-8006-4F61-93F8-4AB6A04320B1}">
   <ds:schemaRefs>
     <ds:schemaRef ds:uri="http://schemas.microsoft.com/office/2006/metadata/contentType"/>
@@ -28534,22 +28402,6 @@
 </ds:datastoreItem>
 </file>
 
-<file path=customXml/itemProps2.xml><?xml version="1.0" encoding="utf-8"?>
-<ds:datastoreItem xmlns:ds="http://schemas.openxmlformats.org/officeDocument/2006/customXml" ds:itemID="{EE15B31B-466C-488E-B171-800C9BAA728E}">
-  <ds:schemaRefs>
-    <ds:schemaRef ds:uri="http://schemas.openxmlformats.org/package/2006/metadata/core-properties"/>
-    <ds:schemaRef ds:uri="http://purl.org/dc/elements/1.1/"/>
-    <ds:schemaRef ds:uri="http://purl.org/dc/terms/"/>
-    <ds:schemaRef ds:uri="http://schemas.microsoft.com/office/2006/metadata/properties"/>
-    <ds:schemaRef ds:uri="http://purl.org/dc/dcmitype/"/>
-    <ds:schemaRef ds:uri="http://schemas.microsoft.com/office/2006/documentManagement/types"/>
-    <ds:schemaRef ds:uri="http://schemas.microsoft.com/office/infopath/2007/PartnerControls"/>
-    <ds:schemaRef ds:uri="49a59b68-094c-48f7-af2b-0072ac24b77e"/>
-    <ds:schemaRef ds:uri="http://www.w3.org/XML/1998/namespace"/>
-  </ds:schemaRefs>
-</ds:datastoreItem>
-</file>
-
 <file path=customXml/itemProps3.xml><?xml version="1.0" encoding="utf-8"?>
 <ds:datastoreItem xmlns:ds="http://schemas.openxmlformats.org/officeDocument/2006/customXml" ds:itemID="{C2223F73-0F08-4D22-88C9-602F4313BC72}">
   <ds:schemaRefs>

</xml_diff>